<commit_message>
optimized parameters for nnetwork
</commit_message>
<xml_diff>
--- a/M8_FOXO:CMYC/MYC:FOXO DLBCL.pptx
+++ b/M8_FOXO:CMYC/MYC:FOXO DLBCL.pptx
@@ -6814,10 +6814,10 @@
       </p:par>
     </p:tnLst>
     <p:bldLst>
+      <p:bldP build="whole" bldLvl="1" animBg="1" rev="0" advAuto="0" spid="202" grpId="4"/>
       <p:bldP build="whole" bldLvl="1" animBg="1" rev="0" advAuto="0" spid="214" grpId="3"/>
       <p:bldP build="whole" bldLvl="1" animBg="1" rev="0" advAuto="0" spid="220" grpId="1"/>
       <p:bldP build="whole" bldLvl="1" animBg="1" rev="0" advAuto="0" spid="220" grpId="2"/>
-      <p:bldP build="whole" bldLvl="1" animBg="1" rev="0" advAuto="0" spid="202" grpId="4"/>
     </p:bldLst>
   </p:timing>
 </p:sld>
@@ -7134,7 +7134,7 @@
       </p:sp>
       <p:pic>
         <p:nvPicPr>
-          <p:cNvPr id="227" name="Screenshot 2020-11-09 at 13.21.42.png" descr="Screenshot 2020-11-09 at 13.21.42.png"/>
+          <p:cNvPr id="227" name="Healthy_A1.jpeg" descr="Healthy_A1.jpeg"/>
           <p:cNvPicPr>
             <a:picLocks noChangeAspect="1"/>
           </p:cNvPicPr>
@@ -7150,8 +7150,8 @@
         </p:blipFill>
         <p:spPr>
           <a:xfrm>
-            <a:off x="2800824" y="4463694"/>
-            <a:ext cx="8714031" cy="5093412"/>
+            <a:off x="2741864" y="3259616"/>
+            <a:ext cx="8540183" cy="6832147"/>
           </a:xfrm>
           <a:prstGeom prst="rect">
             <a:avLst/>
@@ -7163,7 +7163,7 @@
       </p:pic>
       <p:pic>
         <p:nvPicPr>
-          <p:cNvPr id="228" name="Screenshot 2020-11-09 at 13.21.50.png" descr="Screenshot 2020-11-09 at 13.21.50.png"/>
+          <p:cNvPr id="228" name="M8_A1.jpeg" descr="M8_A1.jpeg"/>
           <p:cNvPicPr>
             <a:picLocks noChangeAspect="1"/>
           </p:cNvPicPr>
@@ -7179,8 +7179,8 @@
         </p:blipFill>
         <p:spPr>
           <a:xfrm>
-            <a:off x="12894387" y="4547758"/>
-            <a:ext cx="9104735" cy="5189063"/>
+            <a:off x="14057138" y="3195669"/>
+            <a:ext cx="8700052" cy="6960042"/>
           </a:xfrm>
           <a:prstGeom prst="rect">
             <a:avLst/>
@@ -10663,11 +10663,11 @@
       </p:par>
     </p:tnLst>
     <p:bldLst>
-      <p:bldP build="whole" bldLvl="1" animBg="1" rev="0" advAuto="0" spid="294" grpId="2"/>
+      <p:bldP build="whole" bldLvl="1" animBg="1" rev="0" advAuto="0" spid="298" grpId="4"/>
       <p:bldP build="whole" bldLvl="1" animBg="1" rev="0" advAuto="0" spid="272" grpId="5"/>
       <p:bldP build="whole" bldLvl="1" animBg="1" rev="0" advAuto="0" spid="286" grpId="3"/>
-      <p:bldP build="whole" bldLvl="1" animBg="1" rev="0" advAuto="0" spid="298" grpId="4"/>
       <p:bldP build="whole" bldLvl="1" animBg="1" rev="0" advAuto="0" spid="294" grpId="1"/>
+      <p:bldP build="whole" bldLvl="1" animBg="1" rev="0" advAuto="0" spid="294" grpId="2"/>
     </p:bldLst>
   </p:timing>
 </p:sld>
@@ -10690,9 +10690,96 @@
           <a:chExt cx="0" cy="0"/>
         </a:xfrm>
       </p:grpSpPr>
+      <p:pic>
+        <p:nvPicPr>
+          <p:cNvPr id="312" name="CMYCFOXO_A1.jpeg" descr="CMYCFOXO_A1.jpeg"/>
+          <p:cNvPicPr>
+            <a:picLocks noChangeAspect="1"/>
+          </p:cNvPicPr>
+          <p:nvPr/>
+        </p:nvPicPr>
+        <p:blipFill>
+          <a:blip r:embed="rId2">
+            <a:extLst/>
+          </a:blip>
+          <a:stretch>
+            <a:fillRect/>
+          </a:stretch>
+        </p:blipFill>
+        <p:spPr>
+          <a:xfrm>
+            <a:off x="16822182" y="4358300"/>
+            <a:ext cx="7641115" cy="6112892"/>
+          </a:xfrm>
+          <a:prstGeom prst="rect">
+            <a:avLst/>
+          </a:prstGeom>
+          <a:ln w="12700">
+            <a:miter lim="400000"/>
+          </a:ln>
+        </p:spPr>
+      </p:pic>
+      <p:pic>
+        <p:nvPicPr>
+          <p:cNvPr id="313" name="CMYCFOXO_A0.5.jpeg" descr="CMYCFOXO_A0.5.jpeg"/>
+          <p:cNvPicPr>
+            <a:picLocks noChangeAspect="1"/>
+          </p:cNvPicPr>
+          <p:nvPr/>
+        </p:nvPicPr>
+        <p:blipFill>
+          <a:blip r:embed="rId3">
+            <a:extLst/>
+          </a:blip>
+          <a:stretch>
+            <a:fillRect/>
+          </a:stretch>
+        </p:blipFill>
+        <p:spPr>
+          <a:xfrm>
+            <a:off x="8334938" y="4487785"/>
+            <a:ext cx="7317402" cy="5853922"/>
+          </a:xfrm>
+          <a:prstGeom prst="rect">
+            <a:avLst/>
+          </a:prstGeom>
+          <a:ln w="12700">
+            <a:miter lim="400000"/>
+          </a:ln>
+        </p:spPr>
+      </p:pic>
+      <p:pic>
+        <p:nvPicPr>
+          <p:cNvPr id="314" name="CMYCFOXO_A0.jpeg" descr="CMYCFOXO_A0.jpeg"/>
+          <p:cNvPicPr>
+            <a:picLocks noChangeAspect="1"/>
+          </p:cNvPicPr>
+          <p:nvPr/>
+        </p:nvPicPr>
+        <p:blipFill>
+          <a:blip r:embed="rId4">
+            <a:extLst/>
+          </a:blip>
+          <a:stretch>
+            <a:fillRect/>
+          </a:stretch>
+        </p:blipFill>
+        <p:spPr>
+          <a:xfrm>
+            <a:off x="813838" y="4539520"/>
+            <a:ext cx="7188065" cy="5750452"/>
+          </a:xfrm>
+          <a:prstGeom prst="rect">
+            <a:avLst/>
+          </a:prstGeom>
+          <a:ln w="12700">
+            <a:miter lim="400000"/>
+          </a:ln>
+        </p:spPr>
+      </p:pic>
       <p:sp>
         <p:nvSpPr>
-          <p:cNvPr id="312" name="bcr0=1…"/>
+          <p:cNvPr id="315" name="bcr0=1…"/>
           <p:cNvSpPr txBox="1"/>
           <p:nvPr/>
         </p:nvSpPr>
@@ -10802,7 +10889,7 @@
       </p:sp>
       <p:sp>
         <p:nvSpPr>
-          <p:cNvPr id="313" name="GRN of PC differentiation in GC (Healthy with cMYC and Foxo)"/>
+          <p:cNvPr id="316" name="GRN of PC differentiation in GC (Healthy with cMYC and Foxo)"/>
           <p:cNvSpPr txBox="1"/>
           <p:nvPr>
             <p:ph type="title" idx="4294967295"/>
@@ -10842,7 +10929,7 @@
       </p:sp>
       <p:sp>
         <p:nvSpPr>
-          <p:cNvPr id="314" name="bcr0=1…"/>
+          <p:cNvPr id="317" name="bcr0=1…"/>
           <p:cNvSpPr txBox="1"/>
           <p:nvPr/>
         </p:nvSpPr>
@@ -10950,117 +11037,38 @@
           </a:p>
         </p:txBody>
       </p:sp>
-      <p:grpSp>
-        <p:nvGrpSpPr>
-          <p:cNvPr id="317" name="Group"/>
-          <p:cNvGrpSpPr/>
+      <p:sp>
+        <p:nvSpPr>
+          <p:cNvPr id="318" name="Line"/>
+          <p:cNvSpPr/>
           <p:nvPr/>
-        </p:nvGrpSpPr>
-        <p:grpSpPr>
-          <a:xfrm>
-            <a:off x="16559897" y="5547828"/>
-            <a:ext cx="7812407" cy="4560080"/>
-            <a:chOff x="0" y="0"/>
-            <a:chExt cx="7812406" cy="4560079"/>
+        </p:nvSpPr>
+        <p:spPr>
+          <a:xfrm flipV="1">
+            <a:off x="20285596" y="5479892"/>
+            <a:ext cx="1" cy="3539508"/>
           </a:xfrm>
-        </p:grpSpPr>
-        <p:pic>
-          <p:nvPicPr>
-            <p:cNvPr id="315" name="Screenshot 2020-11-09 at 12.42.36.png" descr="Screenshot 2020-11-09 at 12.42.36.png"/>
-            <p:cNvPicPr>
-              <a:picLocks noChangeAspect="1"/>
-            </p:cNvPicPr>
-            <p:nvPr/>
-          </p:nvPicPr>
-          <p:blipFill>
-            <a:blip r:embed="rId2">
-              <a:extLst/>
-            </a:blip>
-            <a:stretch>
-              <a:fillRect/>
-            </a:stretch>
-          </p:blipFill>
-          <p:spPr>
-            <a:xfrm>
-              <a:off x="0" y="0"/>
-              <a:ext cx="7812407" cy="4560080"/>
-            </a:xfrm>
-            <a:prstGeom prst="rect">
-              <a:avLst/>
-            </a:prstGeom>
-            <a:ln w="12700" cap="flat">
-              <a:noFill/>
-              <a:miter lim="400000"/>
-            </a:ln>
-            <a:effectLst/>
-          </p:spPr>
-        </p:pic>
-        <p:sp>
-          <p:nvSpPr>
-            <p:cNvPr id="316" name="Line"/>
-            <p:cNvSpPr/>
-            <p:nvPr/>
-          </p:nvSpPr>
-          <p:spPr>
-            <a:xfrm flipV="1">
-              <a:off x="4689462" y="106308"/>
-              <a:ext cx="1" cy="3539508"/>
-            </a:xfrm>
-            <a:prstGeom prst="line">
-              <a:avLst/>
-            </a:prstGeom>
-            <a:noFill/>
-            <a:ln w="76200" cap="rnd">
-              <a:solidFill>
-                <a:srgbClr val="FF2600"/>
-              </a:solidFill>
-              <a:custDash>
-                <a:ds d="100000" sp="200000"/>
-              </a:custDash>
-              <a:miter lim="400000"/>
-            </a:ln>
-            <a:effectLst/>
-          </p:spPr>
-          <p:txBody>
-            <a:bodyPr wrap="square" lIns="50800" tIns="50800" rIns="50800" bIns="50800" numCol="1" anchor="ctr">
-              <a:noAutofit/>
-            </a:bodyPr>
-            <a:lstStyle/>
-            <a:p>
-              <a:pPr/>
-            </a:p>
-          </p:txBody>
-        </p:sp>
-      </p:grpSp>
-      <p:pic>
-        <p:nvPicPr>
-          <p:cNvPr id="318" name="Screenshot 2020-11-09 at 12.47.32.png" descr="Screenshot 2020-11-09 at 12.47.32.png"/>
-          <p:cNvPicPr>
-            <a:picLocks noChangeAspect="1"/>
-          </p:cNvPicPr>
-          <p:nvPr/>
-        </p:nvPicPr>
-        <p:blipFill>
-          <a:blip r:embed="rId3">
-            <a:extLst/>
-          </a:blip>
-          <a:stretch>
-            <a:fillRect/>
-          </a:stretch>
-        </p:blipFill>
-        <p:spPr>
-          <a:xfrm>
-            <a:off x="8053298" y="5529905"/>
-            <a:ext cx="8277404" cy="4829698"/>
-          </a:xfrm>
-          <a:prstGeom prst="rect">
+          <a:prstGeom prst="line">
             <a:avLst/>
           </a:prstGeom>
-          <a:ln w="12700">
+          <a:ln w="76200" cap="rnd">
+            <a:solidFill>
+              <a:srgbClr val="FF2600"/>
+            </a:solidFill>
+            <a:custDash>
+              <a:ds d="100000" sp="200000"/>
+            </a:custDash>
             <a:miter lim="400000"/>
           </a:ln>
         </p:spPr>
-      </p:pic>
+        <p:txBody>
+          <a:bodyPr lIns="50800" tIns="50800" rIns="50800" bIns="50800" anchor="ctr"/>
+          <a:lstStyle/>
+          <a:p>
+            <a:pPr/>
+          </a:p>
+        </p:txBody>
+      </p:sp>
       <p:sp>
         <p:nvSpPr>
           <p:cNvPr id="319" name="Line"/>
@@ -11069,7 +11077,7 @@
         </p:nvSpPr>
         <p:spPr>
           <a:xfrm flipV="1">
-            <a:off x="13188528" y="5568358"/>
+            <a:off x="11636496" y="5403258"/>
             <a:ext cx="1" cy="3667376"/>
           </a:xfrm>
           <a:prstGeom prst="line">
@@ -11095,14 +11103,14 @@
       </p:sp>
       <p:sp>
         <p:nvSpPr>
-          <p:cNvPr id="320" name="CBs recycling takes 10 hrs (MYC increase)…"/>
+          <p:cNvPr id="320" name="CCs recycling calculate their divisions soon after rescue. Then they wait for 10 hrs before turning to CBs.…"/>
           <p:cNvSpPr txBox="1"/>
           <p:nvPr/>
         </p:nvSpPr>
         <p:spPr>
           <a:xfrm>
-            <a:off x="7304034" y="3459131"/>
-            <a:ext cx="10691179" cy="854711"/>
+            <a:off x="7190090" y="3177138"/>
+            <a:ext cx="14950124" cy="854711"/>
           </a:xfrm>
           <a:prstGeom prst="rect">
             <a:avLst/>
@@ -11130,7 +11138,7 @@
               </a:defRPr>
             </a:pPr>
             <a:r>
-              <a:t>CBs recycling takes 10 hrs (MYC increase)</a:t>
+              <a:t>CCs recycling calculate their divisions soon after rescue. Then they wait for 10 hrs before turning to CBs.</a:t>
             </a:r>
           </a:p>
           <a:p>
@@ -11257,44 +11265,15 @@
           </a:p>
         </p:txBody>
       </p:sp>
-      <p:pic>
-        <p:nvPicPr>
-          <p:cNvPr id="322" name="Screenshot 2020-11-09 at 13.12.37.png" descr="Screenshot 2020-11-09 at 13.12.37.png"/>
-          <p:cNvPicPr>
-            <a:picLocks noChangeAspect="1"/>
-          </p:cNvPicPr>
-          <p:nvPr/>
-        </p:nvPicPr>
-        <p:blipFill>
-          <a:blip r:embed="rId4">
-            <a:extLst/>
-          </a:blip>
-          <a:stretch>
-            <a:fillRect/>
-          </a:stretch>
-        </p:blipFill>
-        <p:spPr>
-          <a:xfrm>
-            <a:off x="91451" y="5437142"/>
-            <a:ext cx="8104319" cy="4735742"/>
-          </a:xfrm>
-          <a:prstGeom prst="rect">
-            <a:avLst/>
-          </a:prstGeom>
-          <a:ln w="12700">
-            <a:miter lim="400000"/>
-          </a:ln>
-        </p:spPr>
-      </p:pic>
       <p:sp>
         <p:nvSpPr>
-          <p:cNvPr id="323" name="Line"/>
+          <p:cNvPr id="322" name="Line"/>
           <p:cNvSpPr/>
           <p:nvPr/>
         </p:nvSpPr>
         <p:spPr>
           <a:xfrm flipV="1">
-            <a:off x="5065988" y="5353526"/>
+            <a:off x="4076127" y="5403258"/>
             <a:ext cx="1" cy="3667376"/>
           </a:xfrm>
           <a:prstGeom prst="line">
@@ -11344,9 +11323,97 @@
           <a:chExt cx="0" cy="0"/>
         </a:xfrm>
       </p:grpSpPr>
+      <p:pic>
+        <p:nvPicPr>
+          <p:cNvPr id="324" name="CMYCFOXO_M8_A1.jpeg" descr="CMYCFOXO_M8_A1.jpeg"/>
+          <p:cNvPicPr>
+            <a:picLocks noChangeAspect="1"/>
+          </p:cNvPicPr>
+          <p:nvPr/>
+        </p:nvPicPr>
+        <p:blipFill>
+          <a:blip r:embed="rId2">
+            <a:extLst/>
+          </a:blip>
+          <a:stretch>
+            <a:fillRect/>
+          </a:stretch>
+        </p:blipFill>
+        <p:spPr>
+          <a:xfrm>
+            <a:off x="15668170" y="4251233"/>
+            <a:ext cx="8243304" cy="6594644"/>
+          </a:xfrm>
+          <a:prstGeom prst="rect">
+            <a:avLst/>
+          </a:prstGeom>
+          <a:ln w="12700">
+            <a:miter lim="400000"/>
+          </a:ln>
+        </p:spPr>
+      </p:pic>
+      <p:pic>
+        <p:nvPicPr>
+          <p:cNvPr id="325" name="CMYCFOXO_M8_A0.5.jpeg" descr="CMYCFOXO_M8_A0.5.jpeg"/>
+          <p:cNvPicPr>
+            <a:picLocks noChangeAspect="1"/>
+          </p:cNvPicPr>
+          <p:nvPr/>
+        </p:nvPicPr>
+        <p:blipFill>
+          <a:blip r:embed="rId3">
+            <a:extLst/>
+          </a:blip>
+          <a:stretch>
+            <a:fillRect/>
+          </a:stretch>
+        </p:blipFill>
+        <p:spPr>
+          <a:xfrm>
+            <a:off x="8022698" y="4281958"/>
+            <a:ext cx="8338604" cy="6670882"/>
+          </a:xfrm>
+          <a:prstGeom prst="rect">
+            <a:avLst/>
+          </a:prstGeom>
+          <a:ln w="12700">
+            <a:miter lim="400000"/>
+          </a:ln>
+        </p:spPr>
+      </p:pic>
+      <p:pic>
+        <p:nvPicPr>
+          <p:cNvPr id="326" name="CMYCFOXO_M8_A0.jpeg" descr="CMYCFOXO_M8_A0.jpeg"/>
+          <p:cNvPicPr>
+            <a:picLocks noChangeAspect="1"/>
+          </p:cNvPicPr>
+          <p:nvPr/>
+        </p:nvPicPr>
+        <p:blipFill>
+          <a:blip r:embed="rId4">
+            <a:extLst/>
+          </a:blip>
+          <a:srcRect l="0" t="0" r="3806" b="0"/>
+          <a:stretch>
+            <a:fillRect/>
+          </a:stretch>
+        </p:blipFill>
+        <p:spPr>
+          <a:xfrm>
+            <a:off x="236897" y="4364970"/>
+            <a:ext cx="7638351" cy="6352457"/>
+          </a:xfrm>
+          <a:prstGeom prst="rect">
+            <a:avLst/>
+          </a:prstGeom>
+          <a:ln w="12700">
+            <a:miter lim="400000"/>
+          </a:ln>
+        </p:spPr>
+      </p:pic>
       <p:sp>
         <p:nvSpPr>
-          <p:cNvPr id="325" name="GRN of PC differentiation in GC (M8 with cMYC and Foxo)"/>
+          <p:cNvPr id="327" name="GRN of PC differentiation in GC (M8 with cMYC and Foxo)"/>
           <p:cNvSpPr txBox="1"/>
           <p:nvPr>
             <p:ph type="title" idx="4294967295"/>
@@ -11386,7 +11453,7 @@
       </p:sp>
       <p:sp>
         <p:nvSpPr>
-          <p:cNvPr id="326" name="bcr0=1…"/>
+          <p:cNvPr id="328" name="bcr0=1…"/>
           <p:cNvSpPr txBox="1"/>
           <p:nvPr/>
         </p:nvSpPr>
@@ -11496,7 +11563,7 @@
       </p:sp>
       <p:sp>
         <p:nvSpPr>
-          <p:cNvPr id="327" name="bcr0=1…"/>
+          <p:cNvPr id="329" name="bcr0=1…"/>
           <p:cNvSpPr txBox="1"/>
           <p:nvPr/>
         </p:nvSpPr>
@@ -11606,61 +11673,7 @@
       </p:sp>
       <p:sp>
         <p:nvSpPr>
-          <p:cNvPr id="328" name="CBs recycling takes 10 hrs (MYC increase)…"/>
-          <p:cNvSpPr txBox="1"/>
-          <p:nvPr/>
-        </p:nvSpPr>
-        <p:spPr>
-          <a:xfrm>
-            <a:off x="7304034" y="3459131"/>
-            <a:ext cx="10691179" cy="854711"/>
-          </a:xfrm>
-          <a:prstGeom prst="rect">
-            <a:avLst/>
-          </a:prstGeom>
-          <a:ln w="12700">
-            <a:miter lim="400000"/>
-          </a:ln>
-          <a:extLst>
-            <a:ext uri="{C572A759-6A51-4108-AA02-DFA0A04FC94B}">
-              <ma14:wrappingTextBoxFlag xmlns:ma14="http://schemas.microsoft.com/office/mac/drawingml/2011/main" val="1"/>
-            </a:ext>
-          </a:extLst>
-        </p:spPr>
-        <p:txBody>
-          <a:bodyPr wrap="none" lIns="50800" tIns="50800" rIns="50800" bIns="50800" anchor="ctr">
-            <a:spAutoFit/>
-          </a:bodyPr>
-          <a:lstStyle/>
-          <a:p>
-            <a:pPr algn="l">
-              <a:defRPr sz="2500">
-                <a:solidFill>
-                  <a:srgbClr val="FF2600"/>
-                </a:solidFill>
-              </a:defRPr>
-            </a:pPr>
-            <a:r>
-              <a:t>CBs recycling takes 10 hrs (MYC increase)</a:t>
-            </a:r>
-          </a:p>
-          <a:p>
-            <a:pPr algn="l">
-              <a:defRPr sz="2500">
-                <a:solidFill>
-                  <a:srgbClr val="000000"/>
-                </a:solidFill>
-              </a:defRPr>
-            </a:pPr>
-            <a:r>
-              <a:t>PC differentiation can take between 10 and 34 hours (recycling + divisions)</a:t>
-            </a:r>
-          </a:p>
-        </p:txBody>
-      </p:sp>
-      <p:sp>
-        <p:nvSpPr>
-          <p:cNvPr id="329" name="bcr0=1…"/>
+          <p:cNvPr id="330" name="bcr0=1…"/>
           <p:cNvSpPr txBox="1"/>
           <p:nvPr/>
         </p:nvSpPr>
@@ -11768,103 +11781,16 @@
           </a:p>
         </p:txBody>
       </p:sp>
-      <p:pic>
-        <p:nvPicPr>
-          <p:cNvPr id="330" name="Screenshot 2020-11-09 at 13.28.00.png" descr="Screenshot 2020-11-09 at 13.28.00.png"/>
-          <p:cNvPicPr>
-            <a:picLocks noChangeAspect="1"/>
-          </p:cNvPicPr>
-          <p:nvPr/>
-        </p:nvPicPr>
-        <p:blipFill>
-          <a:blip r:embed="rId2">
-            <a:extLst/>
-          </a:blip>
-          <a:stretch>
-            <a:fillRect/>
-          </a:stretch>
-        </p:blipFill>
-        <p:spPr>
-          <a:xfrm>
-            <a:off x="343107" y="5570616"/>
-            <a:ext cx="7555618" cy="4458616"/>
-          </a:xfrm>
-          <a:prstGeom prst="rect">
-            <a:avLst/>
-          </a:prstGeom>
-          <a:ln w="12700">
-            <a:miter lim="400000"/>
-          </a:ln>
-        </p:spPr>
-      </p:pic>
-      <p:pic>
-        <p:nvPicPr>
-          <p:cNvPr id="331" name="Screenshot 2020-11-09 at 13.28.10.png" descr="Screenshot 2020-11-09 at 13.28.10.png"/>
-          <p:cNvPicPr>
-            <a:picLocks noChangeAspect="1"/>
-          </p:cNvPicPr>
-          <p:nvPr/>
-        </p:nvPicPr>
-        <p:blipFill>
-          <a:blip r:embed="rId3">
-            <a:extLst/>
-          </a:blip>
-          <a:stretch>
-            <a:fillRect/>
-          </a:stretch>
-        </p:blipFill>
-        <p:spPr>
-          <a:xfrm>
-            <a:off x="7967706" y="5564266"/>
-            <a:ext cx="7567869" cy="4471316"/>
-          </a:xfrm>
-          <a:prstGeom prst="rect">
-            <a:avLst/>
-          </a:prstGeom>
-          <a:ln w="12700">
-            <a:miter lim="400000"/>
-          </a:ln>
-        </p:spPr>
-      </p:pic>
-      <p:pic>
-        <p:nvPicPr>
-          <p:cNvPr id="332" name="Screenshot 2020-11-09 at 13.28.19.png" descr="Screenshot 2020-11-09 at 13.28.19.png"/>
-          <p:cNvPicPr>
-            <a:picLocks noChangeAspect="1"/>
-          </p:cNvPicPr>
-          <p:nvPr/>
-        </p:nvPicPr>
-        <p:blipFill>
-          <a:blip r:embed="rId4">
-            <a:extLst/>
-          </a:blip>
-          <a:stretch>
-            <a:fillRect/>
-          </a:stretch>
-        </p:blipFill>
-        <p:spPr>
-          <a:xfrm>
-            <a:off x="16144586" y="5645305"/>
-            <a:ext cx="7555618" cy="4403010"/>
-          </a:xfrm>
-          <a:prstGeom prst="rect">
-            <a:avLst/>
-          </a:prstGeom>
-          <a:ln w="12700">
-            <a:miter lim="400000"/>
-          </a:ln>
-        </p:spPr>
-      </p:pic>
       <p:sp>
         <p:nvSpPr>
-          <p:cNvPr id="333" name="Line"/>
+          <p:cNvPr id="331" name="Line"/>
           <p:cNvSpPr/>
           <p:nvPr/>
         </p:nvSpPr>
         <p:spPr>
           <a:xfrm flipV="1">
-            <a:off x="12649623" y="5389014"/>
-            <a:ext cx="1" cy="3667377"/>
+            <a:off x="11771661" y="5624498"/>
+            <a:ext cx="1" cy="3667376"/>
           </a:xfrm>
           <a:prstGeom prst="line">
             <a:avLst/>
@@ -11889,14 +11815,14 @@
       </p:sp>
       <p:sp>
         <p:nvSpPr>
-          <p:cNvPr id="334" name="Line"/>
+          <p:cNvPr id="332" name="Line"/>
           <p:cNvSpPr/>
           <p:nvPr/>
         </p:nvSpPr>
         <p:spPr>
           <a:xfrm flipV="1">
-            <a:off x="4952044" y="5376314"/>
-            <a:ext cx="1" cy="3667377"/>
+            <a:off x="3850050" y="5508626"/>
+            <a:ext cx="1" cy="3667376"/>
           </a:xfrm>
           <a:prstGeom prst="line">
             <a:avLst/>
@@ -11921,14 +11847,14 @@
       </p:sp>
       <p:sp>
         <p:nvSpPr>
-          <p:cNvPr id="335" name="Line"/>
+          <p:cNvPr id="333" name="Line"/>
           <p:cNvSpPr/>
           <p:nvPr/>
         </p:nvSpPr>
         <p:spPr>
           <a:xfrm flipV="1">
-            <a:off x="20817572" y="5389014"/>
-            <a:ext cx="1" cy="3667377"/>
+            <a:off x="19425201" y="5624498"/>
+            <a:ext cx="1" cy="3667376"/>
           </a:xfrm>
           <a:prstGeom prst="line">
             <a:avLst/>
@@ -11948,6 +11874,60 @@
           <a:lstStyle/>
           <a:p>
             <a:pPr/>
+          </a:p>
+        </p:txBody>
+      </p:sp>
+      <p:sp>
+        <p:nvSpPr>
+          <p:cNvPr id="334" name="CCs recycling calculate their divisions soon after rescue. Then they wait for 10 hrs before turning to CBs.…"/>
+          <p:cNvSpPr txBox="1"/>
+          <p:nvPr/>
+        </p:nvSpPr>
+        <p:spPr>
+          <a:xfrm>
+            <a:off x="7190090" y="3177138"/>
+            <a:ext cx="14950124" cy="854711"/>
+          </a:xfrm>
+          <a:prstGeom prst="rect">
+            <a:avLst/>
+          </a:prstGeom>
+          <a:ln w="12700">
+            <a:miter lim="400000"/>
+          </a:ln>
+          <a:extLst>
+            <a:ext uri="{C572A759-6A51-4108-AA02-DFA0A04FC94B}">
+              <ma14:wrappingTextBoxFlag xmlns:ma14="http://schemas.microsoft.com/office/mac/drawingml/2011/main" val="1"/>
+            </a:ext>
+          </a:extLst>
+        </p:spPr>
+        <p:txBody>
+          <a:bodyPr wrap="none" lIns="50800" tIns="50800" rIns="50800" bIns="50800" anchor="ctr">
+            <a:spAutoFit/>
+          </a:bodyPr>
+          <a:lstStyle/>
+          <a:p>
+            <a:pPr algn="l">
+              <a:defRPr sz="2500">
+                <a:solidFill>
+                  <a:srgbClr val="FF2600"/>
+                </a:solidFill>
+              </a:defRPr>
+            </a:pPr>
+            <a:r>
+              <a:t>CCs recycling calculate their divisions soon after rescue. Then they wait for 10 hrs before turning to CBs.</a:t>
+            </a:r>
+          </a:p>
+          <a:p>
+            <a:pPr algn="l">
+              <a:defRPr sz="2500">
+                <a:solidFill>
+                  <a:srgbClr val="000000"/>
+                </a:solidFill>
+              </a:defRPr>
+            </a:pPr>
+            <a:r>
+              <a:t>PC differentiation can take between 10 and 34 hours (recycling + divisions)</a:t>
+            </a:r>
           </a:p>
         </p:txBody>
       </p:sp>

</xml_diff>